<commit_message>
Tugas 1: isi nama dan NIM di sampul laporan dan slide judul
Co-Authored-By: Claude Opus 5.5 <noreply@anthropic.com>
</commit_message>
<xml_diff>
--- a/tugas1/hasil/Tugas1_DistribusiEffort_Phoenix_Slide.pptx
+++ b/tugas1/hasil/Tugas1_DistribusiEffort_Phoenix_Slide.pptx
@@ -4821,11 +4821,11 @@
             <a:r>
               <a:rPr sz="1300" b="0" i="0">
                 <a:solidFill>
-                  <a:srgbClr val="D03B3B"/>
-                </a:solidFill>
-                <a:latin typeface="Calibri"/>
-              </a:rPr>
-              <a:t>[isi nama]</a:t>
+                  <a:srgbClr val="1F1F1F"/>
+                </a:solidFill>
+                <a:latin typeface="Calibri"/>
+              </a:rPr>
+              <a:t>EKA PUTRA KURNIA</a:t>
             </a:r>
           </a:p>
           <a:p>
@@ -4846,11 +4846,11 @@
             <a:r>
               <a:rPr sz="1300" b="0" i="0">
                 <a:solidFill>
-                  <a:srgbClr val="D03B3B"/>
-                </a:solidFill>
-                <a:latin typeface="Calibri"/>
-              </a:rPr>
-              <a:t>[isi NIM]</a:t>
+                  <a:srgbClr val="1F1F1F"/>
+                </a:solidFill>
+                <a:latin typeface="Calibri"/>
+              </a:rPr>
+              <a:t>25.55.2927</a:t>
             </a:r>
           </a:p>
           <a:p>

</xml_diff>